<commit_message>
Polish for submission: high-risk reframe, side-by-side example, screenshot, gitignore cleanup
</commit_message>
<xml_diff>
--- a/Slides/slides.pptx
+++ b/Slides/slides.pptx
@@ -4908,80 +4908,30 @@
           </a:p>
         </p:txBody>
       </p:sp>
-      <p:sp>
-        <p:nvSpPr>
-          <p:cNvPr id="16" name="Rectangle 15"/>
-          <p:cNvSpPr/>
+      <p:pic>
+        <p:nvPicPr>
+          <p:cNvPr id="16" name="Picture 15" descr="app_screenshot.png"/>
+          <p:cNvPicPr>
+            <a:picLocks noChangeAspect="1"/>
+          </p:cNvPicPr>
           <p:nvPr/>
-        </p:nvSpPr>
-        <p:spPr>
-          <a:xfrm>
-            <a:off x="8595360" y="1280160"/>
-            <a:ext cx="3108960" cy="4937760"/>
+        </p:nvPicPr>
+        <p:blipFill>
+          <a:blip r:embed="rId2"/>
+          <a:stretch>
+            <a:fillRect/>
+          </a:stretch>
+        </p:blipFill>
+        <p:spPr>
+          <a:xfrm>
+            <a:off x="9014268" y="1280160"/>
+            <a:ext cx="2271143" cy="4937760"/>
           </a:xfrm>
           <a:prstGeom prst="rect">
             <a:avLst/>
           </a:prstGeom>
-          <a:solidFill>
-            <a:srgbClr val="FFFFFF"/>
-          </a:solidFill>
-          <a:ln w="12700">
-            <a:solidFill>
-              <a:srgbClr val="C7C7CC"/>
-            </a:solidFill>
-            <a:prstDash val="lgDash"/>
-          </a:ln>
-        </p:spPr>
-        <p:style>
-          <a:lnRef idx="1">
-            <a:schemeClr val="accent1"/>
-          </a:lnRef>
-          <a:fillRef idx="3">
-            <a:schemeClr val="accent1"/>
-          </a:fillRef>
-          <a:effectRef idx="2">
-            <a:schemeClr val="accent1"/>
-          </a:effectRef>
-          <a:fontRef idx="minor">
-            <a:schemeClr val="lt1"/>
-          </a:fontRef>
-        </p:style>
-        <p:txBody>
-          <a:bodyPr rtlCol="0" anchor="ctr"/>
-          <a:lstStyle/>
-          <a:p>
-            <a:pPr algn="ctr"/>
-            <a:r>
-              <a:rPr sz="1400" b="0">
-                <a:solidFill>
-                  <a:srgbClr val="6B6B70"/>
-                </a:solidFill>
-                <a:latin typeface="Helvetica Neue"/>
-              </a:rPr>
-              <a:t>[App screenshot]</a:t>
-            </a:r>
-          </a:p>
-          <a:p>
-            <a:pPr algn="ctr">
-              <a:spcBef>
-                <a:spcPts val="600"/>
-              </a:spcBef>
-              <a:spcAft>
-                <a:spcPts val="600"/>
-              </a:spcAft>
-            </a:pPr>
-            <a:r>
-              <a:rPr sz="1100" b="0">
-                <a:solidFill>
-                  <a:srgbClr val="6B6B70"/>
-                </a:solidFill>
-                <a:latin typeface="Helvetica Neue"/>
-              </a:rPr>
-              <a:t>Drop in the segmented control + insights card view</a:t>
-            </a:r>
-          </a:p>
-        </p:txBody>
-      </p:sp>
+        </p:spPr>
+      </p:pic>
       <p:sp>
         <p:nvSpPr>
           <p:cNvPr id="17" name="TextBox 16"/>

</xml_diff>